<commit_message>
MCP demo readme updated
</commit_message>
<xml_diff>
--- a/Model Context Protocol Introduction.pptx
+++ b/Model Context Protocol Introduction.pptx
@@ -22233,7 +22233,7 @@
                 </a:solidFill>
                 <a:sym typeface="+mn-ea"/>
               </a:rPr>
-              <a:t>MCP Architecture</a:t>
+              <a:t>Discussion on MCP Architecture</a:t>
             </a:r>
             <a:endParaRPr lang="en-US" sz="3600">
               <a:solidFill>
@@ -22254,7 +22254,7 @@
                   <a:srgbClr val="002060"/>
                 </a:solidFill>
               </a:rPr>
-              <a:t>Connecting with existing MCP Servers</a:t>
+              <a:t>Connecting with existing MCP Servers with Claude Desktop</a:t>
             </a:r>
             <a:endParaRPr lang="en-US" sz="3600">
               <a:solidFill>
@@ -22274,7 +22274,16 @@
                   <a:srgbClr val="002060"/>
                 </a:solidFill>
               </a:rPr>
-              <a:t>Connecting with local DB using MCP Server</a:t>
+              <a:t>Connecting with local DB using MCP Server </a:t>
+            </a:r>
+            <a:r>
+              <a:rPr lang="en-US" sz="3600">
+                <a:solidFill>
+                  <a:srgbClr val="002060"/>
+                </a:solidFill>
+                <a:sym typeface="+mn-ea"/>
+              </a:rPr>
+              <a:t>with Claude Desktop</a:t>
             </a:r>
             <a:endParaRPr lang="en-US" sz="3600">
               <a:solidFill>

</xml_diff>